<commit_message>
Add two-column slide layout
</commit_message>
<xml_diff>
--- a/examples/sample.pptx
+++ b/examples/sample.pptx
@@ -2,12 +2,13 @@
 <file path=ppt/presentation.xml><?xml version="1.0" encoding="utf-8"?>
 <p:presentation xmlns:a="http://schemas.openxmlformats.org/drawingml/2006/main" xmlns:r="http://schemas.openxmlformats.org/officeDocument/2006/relationships" xmlns:p="http://schemas.openxmlformats.org/presentationml/2006/main">
   <p:sldMasterIdLst>
-    <p:sldMasterId id="2147483648" r:id="rId4"/>
+    <p:sldMasterId id="2147483648" r:id="rId5"/>
   </p:sldMasterIdLst>
   <p:sldIdLst>
     <p:sldId id="256" r:id="rId1"/>
     <p:sldId id="257" r:id="rId2"/>
     <p:sldId id="258" r:id="rId3"/>
+    <p:sldId id="259" r:id="rId4"/>
   </p:sldIdLst>
   <p:sldSz cx="12192000" cy="6858000" type="screen16x9"/>
   <p:notesSz cx="6858000" cy="9144000"/>
@@ -200,6 +201,9 @@
             </a:r>
             <a:r>
               <a:rPr lang="en-US" sz="2000">
+                <a:highlight>
+                  <a:srgbClr val="F9F2F4"/>
+                </a:highlight>
                 <a:solidFill>
                   <a:srgbClr val="C7254E"/>
                 </a:solidFill>
@@ -228,6 +232,88 @@
         <p:spPr>
           <a:xfrm>
             <a:off x="863600" y="1483360"/>
+            <a:ext cx="10820400" cy="1005840"/>
+          </a:xfrm>
+          <a:prstGeom prst="rect">
+            <a:avLst/>
+          </a:prstGeom>
+          <a:noFill/>
+          <a:ln>
+            <a:noFill/>
+          </a:ln>
+        </p:spPr>
+        <p:txBody>
+          <a:bodyPr wrap="square"/>
+          <a:lstStyle/>
+          <a:p>
+            <a:r>
+              <a:rPr lang="en-US" sz="2200">
+                <a:solidFill>
+                  <a:srgbClr val="222222"/>
+                </a:solidFill>
+                <a:latin typeface="Arial"/>
+              </a:rPr>
+              <a:t>- </a:t>
+            </a:r>
+            <a:r>
+              <a:rPr lang="en-US" sz="2200">
+                <a:solidFill>
+                  <a:srgbClr val="222222"/>
+                </a:solidFill>
+                <a:latin typeface="Arial"/>
+              </a:rPr>
+              <a:t>スライドは </a:t>
+            </a:r>
+            <a:r>
+              <a:rPr lang="en-US" sz="2200">
+                <a:solidFill>
+                  <a:srgbClr val="222222"/>
+                </a:solidFill>
+                <a:latin typeface="Arial"/>
+              </a:rPr>
+              <a:t>
+</a:t>
+            </a:r>
+            <a:r>
+              <a:rPr lang="en-US" sz="2200">
+                <a:solidFill>
+                  <a:srgbClr val="222222"/>
+                </a:solidFill>
+                <a:latin typeface="Arial"/>
+              </a:rPr>
+              <a:t>---</a:t>
+            </a:r>
+            <a:r>
+              <a:rPr lang="en-US" sz="2200">
+                <a:solidFill>
+                  <a:srgbClr val="222222"/>
+                </a:solidFill>
+                <a:latin typeface="Arial"/>
+              </a:rPr>
+              <a:t>
+</a:t>
+            </a:r>
+            <a:r>
+              <a:rPr lang="en-US" sz="2200">
+                <a:solidFill>
+                  <a:srgbClr val="222222"/>
+                </a:solidFill>
+                <a:latin typeface="Arial"/>
+              </a:rPr>
+              <a:t> で分割</a:t>
+            </a:r>
+          </a:p>
+        </p:txBody>
+      </p:sp>
+      <p:sp>
+        <p:nvSpPr>
+          <p:cNvPr id="5" name="Text 5"/>
+          <p:cNvSpPr txBox="1"/>
+          <p:nvPr/>
+        </p:nvSpPr>
+        <p:spPr>
+          <a:xfrm>
+            <a:off x="863600" y="2590800"/>
             <a:ext cx="10820400" cy="335280"/>
           </a:xfrm>
           <a:prstGeom prst="rect">
@@ -258,68 +344,6 @@
                 </a:solidFill>
                 <a:latin typeface="Arial"/>
               </a:rPr>
-              <a:t>スライドは </a:t>
-            </a:r>
-            <a:r>
-              <a:rPr lang="en-US" sz="2200">
-                <a:solidFill>
-                  <a:srgbClr val="222222"/>
-                </a:solidFill>
-                <a:latin typeface="Arial"/>
-              </a:rPr>
-              <a:t>---</a:t>
-            </a:r>
-            <a:r>
-              <a:rPr lang="en-US" sz="2200">
-                <a:solidFill>
-                  <a:srgbClr val="222222"/>
-                </a:solidFill>
-                <a:latin typeface="Arial"/>
-              </a:rPr>
-              <a:t> で分割</a:t>
-            </a:r>
-          </a:p>
-        </p:txBody>
-      </p:sp>
-      <p:sp>
-        <p:nvSpPr>
-          <p:cNvPr id="5" name="Text 5"/>
-          <p:cNvSpPr txBox="1"/>
-          <p:nvPr/>
-        </p:nvSpPr>
-        <p:spPr>
-          <a:xfrm>
-            <a:off x="863600" y="1920240"/>
-            <a:ext cx="10820400" cy="335280"/>
-          </a:xfrm>
-          <a:prstGeom prst="rect">
-            <a:avLst/>
-          </a:prstGeom>
-          <a:noFill/>
-          <a:ln>
-            <a:noFill/>
-          </a:ln>
-        </p:spPr>
-        <p:txBody>
-          <a:bodyPr wrap="square"/>
-          <a:lstStyle/>
-          <a:p>
-            <a:r>
-              <a:rPr lang="en-US" sz="2200">
-                <a:solidFill>
-                  <a:srgbClr val="222222"/>
-                </a:solidFill>
-                <a:latin typeface="Arial"/>
-              </a:rPr>
-              <a:t>- </a:t>
-            </a:r>
-            <a:r>
-              <a:rPr lang="en-US" sz="2200">
-                <a:solidFill>
-                  <a:srgbClr val="222222"/>
-                </a:solidFill>
-                <a:latin typeface="Arial"/>
-              </a:rPr>
               <a:t>箇条書きに対応</a:t>
             </a:r>
           </a:p>
@@ -333,7 +357,7 @@
         </p:nvSpPr>
         <p:spPr>
           <a:xfrm>
-            <a:off x="863600" y="2357120"/>
+            <a:off x="863600" y="3027680"/>
             <a:ext cx="10820400" cy="335280"/>
           </a:xfrm>
           <a:prstGeom prst="rect">
@@ -735,6 +759,469 @@
                 <a:latin typeface="Arial"/>
               </a:rPr>
               <a:t>複雑なレイアウトは今後追加</a:t>
+            </a:r>
+          </a:p>
+        </p:txBody>
+      </p:sp>
+    </p:spTree>
+  </p:cSld>
+  <p:clrMapOvr>
+    <a:masterClrMapping/>
+  </p:clrMapOvr>
+</p:sld>
+</file>
+
+<file path=ppt/slides/slide4.xml><?xml version="1.0" encoding="utf-8"?>
+<p:sld xmlns:a="http://schemas.openxmlformats.org/drawingml/2006/main" xmlns:r="http://schemas.openxmlformats.org/officeDocument/2006/relationships" xmlns:p="http://schemas.openxmlformats.org/presentationml/2006/main">
+  <p:cSld>
+    <p:bg>
+      <p:bgPr>
+        <a:solidFill>
+          <a:srgbClr val="FFFFFF"/>
+        </a:solidFill>
+        <a:effectLst/>
+      </p:bgPr>
+    </p:bg>
+    <p:spTree>
+      <p:nvGrpSpPr>
+        <p:cNvPr id="1" name=""/>
+        <p:cNvGrpSpPr/>
+        <p:nvPr/>
+      </p:nvGrpSpPr>
+      <p:grpSpPr>
+        <a:xfrm>
+          <a:off x="0" y="0"/>
+          <a:ext cx="0" cy="0"/>
+          <a:chOff x="0" y="0"/>
+          <a:chExt cx="0" cy="0"/>
+        </a:xfrm>
+      </p:grpSpPr>
+      <p:sp>
+        <p:nvSpPr>
+          <p:cNvPr id="2" name="Text 2"/>
+          <p:cNvSpPr txBox="1"/>
+          <p:nvPr/>
+        </p:nvSpPr>
+        <p:spPr>
+          <a:xfrm>
+            <a:off x="508000" y="508000"/>
+            <a:ext cx="11176000" cy="548640"/>
+          </a:xfrm>
+          <a:prstGeom prst="rect">
+            <a:avLst/>
+          </a:prstGeom>
+          <a:noFill/>
+          <a:ln>
+            <a:noFill/>
+          </a:ln>
+        </p:spPr>
+        <p:txBody>
+          <a:bodyPr wrap="square"/>
+          <a:lstStyle/>
+          <a:p>
+            <a:r>
+              <a:rPr lang="en-US" sz="3600" b="1">
+                <a:solidFill>
+                  <a:srgbClr val="111111"/>
+                </a:solidFill>
+                <a:latin typeface="Arial"/>
+              </a:rPr>
+              <a:t>Two Columns</a:t>
+            </a:r>
+          </a:p>
+        </p:txBody>
+      </p:sp>
+      <p:sp>
+        <p:nvSpPr>
+          <p:cNvPr id="3" name="Text 3"/>
+          <p:cNvSpPr txBox="1"/>
+          <p:nvPr/>
+        </p:nvSpPr>
+        <p:spPr>
+          <a:xfrm>
+            <a:off x="508000" y="1361440"/>
+            <a:ext cx="5435600" cy="438150"/>
+          </a:xfrm>
+          <a:prstGeom prst="rect">
+            <a:avLst/>
+          </a:prstGeom>
+          <a:noFill/>
+          <a:ln>
+            <a:noFill/>
+          </a:ln>
+        </p:spPr>
+        <p:txBody>
+          <a:bodyPr wrap="square"/>
+          <a:lstStyle/>
+          <a:p>
+            <a:r>
+              <a:rPr lang="en-US" sz="3000" b="1">
+                <a:solidFill>
+                  <a:srgbClr val="222222"/>
+                </a:solidFill>
+                <a:latin typeface="Arial"/>
+              </a:rPr>
+              <a:t>Left</a:t>
+            </a:r>
+          </a:p>
+        </p:txBody>
+      </p:sp>
+      <p:sp>
+        <p:nvSpPr>
+          <p:cNvPr id="4" name="Text 4"/>
+          <p:cNvSpPr txBox="1"/>
+          <p:nvPr/>
+        </p:nvSpPr>
+        <p:spPr>
+          <a:xfrm>
+            <a:off x="863600" y="1977390"/>
+            <a:ext cx="5080000" cy="335280"/>
+          </a:xfrm>
+          <a:prstGeom prst="rect">
+            <a:avLst/>
+          </a:prstGeom>
+          <a:noFill/>
+          <a:ln>
+            <a:noFill/>
+          </a:ln>
+        </p:spPr>
+        <p:txBody>
+          <a:bodyPr wrap="square"/>
+          <a:lstStyle/>
+          <a:p>
+            <a:r>
+              <a:rPr lang="en-US" sz="2200">
+                <a:solidFill>
+                  <a:srgbClr val="222222"/>
+                </a:solidFill>
+                <a:latin typeface="Arial"/>
+              </a:rPr>
+              <a:t>- </a:t>
+            </a:r>
+            <a:r>
+              <a:rPr lang="en-US" sz="2200">
+                <a:solidFill>
+                  <a:srgbClr val="222222"/>
+                </a:solidFill>
+                <a:latin typeface="Arial"/>
+              </a:rPr>
+              <a:t>箇条書き</a:t>
+            </a:r>
+          </a:p>
+        </p:txBody>
+      </p:sp>
+      <p:sp>
+        <p:nvSpPr>
+          <p:cNvPr id="5" name="Text 5"/>
+          <p:cNvSpPr txBox="1"/>
+          <p:nvPr/>
+        </p:nvSpPr>
+        <p:spPr>
+          <a:xfrm>
+            <a:off x="863600" y="2414270"/>
+            <a:ext cx="5080000" cy="335280"/>
+          </a:xfrm>
+          <a:prstGeom prst="rect">
+            <a:avLst/>
+          </a:prstGeom>
+          <a:noFill/>
+          <a:ln>
+            <a:noFill/>
+          </a:ln>
+        </p:spPr>
+        <p:txBody>
+          <a:bodyPr wrap="square"/>
+          <a:lstStyle/>
+          <a:p>
+            <a:r>
+              <a:rPr lang="en-US" sz="2200">
+                <a:solidFill>
+                  <a:srgbClr val="222222"/>
+                </a:solidFill>
+                <a:latin typeface="Arial"/>
+              </a:rPr>
+              <a:t>- </a:t>
+            </a:r>
+            <a:r>
+              <a:rPr lang="en-US" sz="2200">
+                <a:solidFill>
+                  <a:srgbClr val="222222"/>
+                </a:solidFill>
+                <a:latin typeface="Arial"/>
+              </a:rPr>
+              <a:t>通常のMarkdown</a:t>
+            </a:r>
+          </a:p>
+        </p:txBody>
+      </p:sp>
+      <p:sp>
+        <p:nvSpPr>
+          <p:cNvPr id="6" name="Text 6"/>
+          <p:cNvSpPr txBox="1"/>
+          <p:nvPr/>
+        </p:nvSpPr>
+        <p:spPr>
+          <a:xfrm>
+            <a:off x="6248400" y="1361440"/>
+            <a:ext cx="5435600" cy="438150"/>
+          </a:xfrm>
+          <a:prstGeom prst="rect">
+            <a:avLst/>
+          </a:prstGeom>
+          <a:noFill/>
+          <a:ln>
+            <a:noFill/>
+          </a:ln>
+        </p:spPr>
+        <p:txBody>
+          <a:bodyPr wrap="square"/>
+          <a:lstStyle/>
+          <a:p>
+            <a:r>
+              <a:rPr lang="en-US" sz="3000" b="1">
+                <a:solidFill>
+                  <a:srgbClr val="222222"/>
+                </a:solidFill>
+                <a:latin typeface="Arial"/>
+              </a:rPr>
+              <a:t>Right</a:t>
+            </a:r>
+          </a:p>
+        </p:txBody>
+      </p:sp>
+      <p:sp>
+        <p:nvSpPr>
+          <p:cNvPr id="7" name="Table Cell 7"/>
+          <p:cNvSpPr txBox="1"/>
+          <p:nvPr/>
+        </p:nvSpPr>
+        <p:spPr>
+          <a:xfrm>
+            <a:off x="6248400" y="1977390"/>
+            <a:ext cx="2717800" cy="487680"/>
+          </a:xfrm>
+          <a:prstGeom prst="rect">
+            <a:avLst/>
+          </a:prstGeom>
+          <a:solidFill>
+            <a:srgbClr val="EEF1F5"/>
+          </a:solidFill>
+          <a:ln w="6350">
+            <a:solidFill>
+              <a:srgbClr val="C9CDD3"/>
+            </a:solidFill>
+          </a:ln>
+        </p:spPr>
+        <p:txBody>
+          <a:bodyPr wrap="square" lIns="76200" tIns="50800" rIns="76200" bIns="50800"/>
+          <a:lstStyle/>
+          <a:p>
+            <a:r>
+              <a:rPr lang="en-US" sz="2200" b="1">
+                <a:solidFill>
+                  <a:srgbClr val="222222"/>
+                </a:solidFill>
+                <a:latin typeface="Arial"/>
+              </a:rPr>
+              <a:t>項目</a:t>
+            </a:r>
+          </a:p>
+        </p:txBody>
+      </p:sp>
+      <p:sp>
+        <p:nvSpPr>
+          <p:cNvPr id="8" name="Table Cell 8"/>
+          <p:cNvSpPr txBox="1"/>
+          <p:nvPr/>
+        </p:nvSpPr>
+        <p:spPr>
+          <a:xfrm>
+            <a:off x="8966200" y="1977390"/>
+            <a:ext cx="2717800" cy="487680"/>
+          </a:xfrm>
+          <a:prstGeom prst="rect">
+            <a:avLst/>
+          </a:prstGeom>
+          <a:solidFill>
+            <a:srgbClr val="EEF1F5"/>
+          </a:solidFill>
+          <a:ln w="6350">
+            <a:solidFill>
+              <a:srgbClr val="C9CDD3"/>
+            </a:solidFill>
+          </a:ln>
+        </p:spPr>
+        <p:txBody>
+          <a:bodyPr wrap="square" lIns="76200" tIns="50800" rIns="76200" bIns="50800"/>
+          <a:lstStyle/>
+          <a:p>
+            <a:pPr algn="r"/>
+            <a:r>
+              <a:rPr lang="en-US" sz="2200" b="1">
+                <a:solidFill>
+                  <a:srgbClr val="222222"/>
+                </a:solidFill>
+                <a:latin typeface="Arial"/>
+              </a:rPr>
+              <a:t>値</a:t>
+            </a:r>
+          </a:p>
+        </p:txBody>
+      </p:sp>
+      <p:sp>
+        <p:nvSpPr>
+          <p:cNvPr id="9" name="Table Cell 9"/>
+          <p:cNvSpPr txBox="1"/>
+          <p:nvPr/>
+        </p:nvSpPr>
+        <p:spPr>
+          <a:xfrm>
+            <a:off x="6248400" y="2465070"/>
+            <a:ext cx="2717800" cy="487680"/>
+          </a:xfrm>
+          <a:prstGeom prst="rect">
+            <a:avLst/>
+          </a:prstGeom>
+          <a:solidFill>
+            <a:srgbClr val="FFFFFF"/>
+          </a:solidFill>
+          <a:ln w="6350">
+            <a:solidFill>
+              <a:srgbClr val="C9CDD3"/>
+            </a:solidFill>
+          </a:ln>
+        </p:spPr>
+        <p:txBody>
+          <a:bodyPr wrap="square" lIns="76200" tIns="50800" rIns="76200" bIns="50800"/>
+          <a:lstStyle/>
+          <a:p>
+            <a:r>
+              <a:rPr lang="en-US" sz="2200">
+                <a:solidFill>
+                  <a:srgbClr val="222222"/>
+                </a:solidFill>
+                <a:latin typeface="Arial"/>
+              </a:rPr>
+              <a:t>A</a:t>
+            </a:r>
+          </a:p>
+        </p:txBody>
+      </p:sp>
+      <p:sp>
+        <p:nvSpPr>
+          <p:cNvPr id="10" name="Table Cell 10"/>
+          <p:cNvSpPr txBox="1"/>
+          <p:nvPr/>
+        </p:nvSpPr>
+        <p:spPr>
+          <a:xfrm>
+            <a:off x="8966200" y="2465070"/>
+            <a:ext cx="2717800" cy="487680"/>
+          </a:xfrm>
+          <a:prstGeom prst="rect">
+            <a:avLst/>
+          </a:prstGeom>
+          <a:solidFill>
+            <a:srgbClr val="FFFFFF"/>
+          </a:solidFill>
+          <a:ln w="6350">
+            <a:solidFill>
+              <a:srgbClr val="C9CDD3"/>
+            </a:solidFill>
+          </a:ln>
+        </p:spPr>
+        <p:txBody>
+          <a:bodyPr wrap="square" lIns="76200" tIns="50800" rIns="76200" bIns="50800"/>
+          <a:lstStyle/>
+          <a:p>
+            <a:pPr algn="r"/>
+            <a:r>
+              <a:rPr lang="en-US" sz="2200">
+                <a:solidFill>
+                  <a:srgbClr val="222222"/>
+                </a:solidFill>
+                <a:latin typeface="Arial"/>
+              </a:rPr>
+              <a:t>10</a:t>
+            </a:r>
+          </a:p>
+        </p:txBody>
+      </p:sp>
+      <p:sp>
+        <p:nvSpPr>
+          <p:cNvPr id="11" name="Table Cell 11"/>
+          <p:cNvSpPr txBox="1"/>
+          <p:nvPr/>
+        </p:nvSpPr>
+        <p:spPr>
+          <a:xfrm>
+            <a:off x="6248400" y="2952750"/>
+            <a:ext cx="2717800" cy="487680"/>
+          </a:xfrm>
+          <a:prstGeom prst="rect">
+            <a:avLst/>
+          </a:prstGeom>
+          <a:solidFill>
+            <a:srgbClr val="FFFFFF"/>
+          </a:solidFill>
+          <a:ln w="6350">
+            <a:solidFill>
+              <a:srgbClr val="C9CDD3"/>
+            </a:solidFill>
+          </a:ln>
+        </p:spPr>
+        <p:txBody>
+          <a:bodyPr wrap="square" lIns="76200" tIns="50800" rIns="76200" bIns="50800"/>
+          <a:lstStyle/>
+          <a:p>
+            <a:r>
+              <a:rPr lang="en-US" sz="2200">
+                <a:solidFill>
+                  <a:srgbClr val="222222"/>
+                </a:solidFill>
+                <a:latin typeface="Arial"/>
+              </a:rPr>
+              <a:t>B</a:t>
+            </a:r>
+          </a:p>
+        </p:txBody>
+      </p:sp>
+      <p:sp>
+        <p:nvSpPr>
+          <p:cNvPr id="12" name="Table Cell 12"/>
+          <p:cNvSpPr txBox="1"/>
+          <p:nvPr/>
+        </p:nvSpPr>
+        <p:spPr>
+          <a:xfrm>
+            <a:off x="8966200" y="2952750"/>
+            <a:ext cx="2717800" cy="487680"/>
+          </a:xfrm>
+          <a:prstGeom prst="rect">
+            <a:avLst/>
+          </a:prstGeom>
+          <a:solidFill>
+            <a:srgbClr val="FFFFFF"/>
+          </a:solidFill>
+          <a:ln w="6350">
+            <a:solidFill>
+              <a:srgbClr val="C9CDD3"/>
+            </a:solidFill>
+          </a:ln>
+        </p:spPr>
+        <p:txBody>
+          <a:bodyPr wrap="square" lIns="76200" tIns="50800" rIns="76200" bIns="50800"/>
+          <a:lstStyle/>
+          <a:p>
+            <a:pPr algn="r"/>
+            <a:r>
+              <a:rPr lang="en-US" sz="2200">
+                <a:solidFill>
+                  <a:srgbClr val="222222"/>
+                </a:solidFill>
+                <a:latin typeface="Arial"/>
+              </a:rPr>
+              <a:t>20</a:t>
             </a:r>
           </a:p>
         </p:txBody>

</xml_diff>

<commit_message>
Fix text wrapping layout estimates
</commit_message>
<xml_diff>
--- a/examples/sample.pptx
+++ b/examples/sample.pptx
@@ -105,28 +105,28 @@
         <p:spPr>
           <a:xfrm>
             <a:off x="508000" y="508000"/>
-            <a:ext cx="11176000" cy="335280"/>
-          </a:xfrm>
-          <a:prstGeom prst="rect">
-            <a:avLst/>
-          </a:prstGeom>
-          <a:noFill/>
-          <a:ln>
-            <a:noFill/>
-          </a:ln>
-        </p:spPr>
-        <p:txBody>
-          <a:bodyPr wrap="square"/>
-          <a:lstStyle/>
-          <a:p>
-            <a:r>
-              <a:rPr lang="en-US" sz="2200">
-                <a:solidFill>
-                  <a:srgbClr val="222222"/>
-                </a:solidFill>
-                <a:latin typeface="Arial"/>
-              </a:rPr>
-              <a:t>﻿# md2pptx Sample</a:t>
+            <a:ext cx="11176000" cy="548640"/>
+          </a:xfrm>
+          <a:prstGeom prst="rect">
+            <a:avLst/>
+          </a:prstGeom>
+          <a:noFill/>
+          <a:ln>
+            <a:noFill/>
+          </a:ln>
+        </p:spPr>
+        <p:txBody>
+          <a:bodyPr wrap="square"/>
+          <a:lstStyle/>
+          <a:p>
+            <a:r>
+              <a:rPr lang="en-US" sz="3600" b="1">
+                <a:solidFill>
+                  <a:srgbClr val="111111"/>
+                </a:solidFill>
+                <a:latin typeface="Arial"/>
+              </a:rPr>
+              <a:t>md2pptx Sample</a:t>
             </a:r>
           </a:p>
         </p:txBody>
@@ -139,8 +139,8 @@
         </p:nvSpPr>
         <p:spPr>
           <a:xfrm>
-            <a:off x="508000" y="995680"/>
-            <a:ext cx="11176000" cy="335280"/>
+            <a:off x="508000" y="1361440"/>
+            <a:ext cx="11176000" cy="670560"/>
           </a:xfrm>
           <a:prstGeom prst="rect">
             <a:avLst/>
@@ -231,8 +231,8 @@
         </p:nvSpPr>
         <p:spPr>
           <a:xfrm>
-            <a:off x="863600" y="1483360"/>
-            <a:ext cx="10820400" cy="1005840"/>
+            <a:off x="863600" y="2184400"/>
+            <a:ext cx="10820400" cy="335280"/>
           </a:xfrm>
           <a:prstGeom prst="rect">
             <a:avLst/>
@@ -265,21 +265,14 @@
               <a:t>スライドは </a:t>
             </a:r>
             <a:r>
-              <a:rPr lang="en-US" sz="2200">
-                <a:solidFill>
-                  <a:srgbClr val="222222"/>
-                </a:solidFill>
-                <a:latin typeface="Arial"/>
-              </a:rPr>
-              <a:t>
-</a:t>
-            </a:r>
-            <a:r>
-              <a:rPr lang="en-US" sz="2200">
-                <a:solidFill>
-                  <a:srgbClr val="222222"/>
-                </a:solidFill>
-                <a:latin typeface="Arial"/>
+              <a:rPr lang="en-US" sz="2000">
+                <a:highlight>
+                  <a:srgbClr val="F9F2F4"/>
+                </a:highlight>
+                <a:solidFill>
+                  <a:srgbClr val="C7254E"/>
+                </a:solidFill>
+                <a:latin typeface="Consolas"/>
               </a:rPr>
               <a:t>---</a:t>
             </a:r>
@@ -290,16 +283,6 @@
                 </a:solidFill>
                 <a:latin typeface="Arial"/>
               </a:rPr>
-              <a:t>
-</a:t>
-            </a:r>
-            <a:r>
-              <a:rPr lang="en-US" sz="2200">
-                <a:solidFill>
-                  <a:srgbClr val="222222"/>
-                </a:solidFill>
-                <a:latin typeface="Arial"/>
-              </a:rPr>
               <a:t> で分割</a:t>
             </a:r>
           </a:p>
@@ -313,7 +296,7 @@
         </p:nvSpPr>
         <p:spPr>
           <a:xfrm>
-            <a:off x="863600" y="2590800"/>
+            <a:off x="863600" y="2621280"/>
             <a:ext cx="10820400" cy="335280"/>
           </a:xfrm>
           <a:prstGeom prst="rect">
@@ -357,7 +340,7 @@
         </p:nvSpPr>
         <p:spPr>
           <a:xfrm>
-            <a:off x="863600" y="3027680"/>
+            <a:off x="863600" y="3058160"/>
             <a:ext cx="10820400" cy="335280"/>
           </a:xfrm>
           <a:prstGeom prst="rect">

</xml_diff>

<commit_message>
Render Mermaid diagrams as SVG
</commit_message>
<xml_diff>
--- a/examples/sample.pptx
+++ b/examples/sample.pptx
@@ -2,13 +2,14 @@
 <file path=ppt/presentation.xml><?xml version="1.0" encoding="utf-8"?>
 <p:presentation xmlns:a="http://schemas.openxmlformats.org/drawingml/2006/main" xmlns:r="http://schemas.openxmlformats.org/officeDocument/2006/relationships" xmlns:p="http://schemas.openxmlformats.org/presentationml/2006/main">
   <p:sldMasterIdLst>
-    <p:sldMasterId id="2147483648" r:id="rId5"/>
+    <p:sldMasterId id="2147483648" r:id="rId6"/>
   </p:sldMasterIdLst>
   <p:sldIdLst>
     <p:sldId id="256" r:id="rId1"/>
     <p:sldId id="257" r:id="rId2"/>
     <p:sldId id="258" r:id="rId3"/>
     <p:sldId id="259" r:id="rId4"/>
+    <p:sldId id="260" r:id="rId5"/>
   </p:sldIdLst>
   <p:sldSz cx="12192000" cy="6858000" type="screen16x9"/>
   <p:notesSz cx="6858000" cy="9144000"/>
@@ -697,7 +698,7 @@
                 </a:solidFill>
                 <a:latin typeface="Arial"/>
               </a:rPr>
-              <a:t>Mermaid と数式は未対応エラー</a:t>
+              <a:t>Mermaid は SVG 図として出力</a:t>
             </a:r>
           </a:p>
         </p:txBody>
@@ -755,6 +756,96 @@
 </file>
 
 <file path=ppt/slides/slide4.xml><?xml version="1.0" encoding="utf-8"?>
+<p:sld xmlns:a="http://schemas.openxmlformats.org/drawingml/2006/main" xmlns:r="http://schemas.openxmlformats.org/officeDocument/2006/relationships" xmlns:p="http://schemas.openxmlformats.org/presentationml/2006/main">
+  <p:cSld>
+    <p:bg>
+      <p:bgPr>
+        <a:solidFill>
+          <a:srgbClr val="FFFFFF"/>
+        </a:solidFill>
+        <a:effectLst/>
+      </p:bgPr>
+    </p:bg>
+    <p:spTree>
+      <p:nvGrpSpPr>
+        <p:cNvPr id="1" name=""/>
+        <p:cNvGrpSpPr/>
+        <p:nvPr/>
+      </p:nvGrpSpPr>
+      <p:grpSpPr>
+        <a:xfrm>
+          <a:off x="0" y="0"/>
+          <a:ext cx="0" cy="0"/>
+          <a:chOff x="0" y="0"/>
+          <a:chExt cx="0" cy="0"/>
+        </a:xfrm>
+      </p:grpSpPr>
+      <p:sp>
+        <p:nvSpPr>
+          <p:cNvPr id="2" name="Text 2"/>
+          <p:cNvSpPr txBox="1"/>
+          <p:nvPr/>
+        </p:nvSpPr>
+        <p:spPr>
+          <a:xfrm>
+            <a:off x="508000" y="508000"/>
+            <a:ext cx="11176000" cy="548640"/>
+          </a:xfrm>
+          <a:prstGeom prst="rect">
+            <a:avLst/>
+          </a:prstGeom>
+          <a:noFill/>
+          <a:ln>
+            <a:noFill/>
+          </a:ln>
+        </p:spPr>
+        <p:txBody>
+          <a:bodyPr wrap="square"/>
+          <a:lstStyle/>
+          <a:p>
+            <a:r>
+              <a:rPr lang="en-US" sz="3600" b="1">
+                <a:solidFill>
+                  <a:srgbClr val="111111"/>
+                </a:solidFill>
+                <a:latin typeface="Arial"/>
+              </a:rPr>
+              <a:t>Mermaid</a:t>
+            </a:r>
+          </a:p>
+        </p:txBody>
+      </p:sp>
+      <p:pic>
+        <p:nvPicPr>
+          <p:cNvPr id="3" name="Mermaid diagram"/>
+          <p:cNvPicPr/>
+          <p:nvPr/>
+        </p:nvPicPr>
+        <p:blipFill>
+          <a:blip r:embed="rId2"/>
+          <a:stretch>
+            <a:fillRect/>
+          </a:stretch>
+        </p:blipFill>
+        <p:spPr>
+          <a:xfrm>
+            <a:off x="508000" y="1361440"/>
+            <a:ext cx="11176000" cy="1545617"/>
+          </a:xfrm>
+          <a:prstGeom prst="rect">
+            <a:avLst/>
+          </a:prstGeom>
+        </p:spPr>
+      </p:pic>
+    </p:spTree>
+  </p:cSld>
+  <p:clrMapOvr>
+    <a:masterClrMapping/>
+  </p:clrMapOvr>
+</p:sld>
+</file>
+
+<file path=ppt/slides/slide5.xml><?xml version="1.0" encoding="utf-8"?>
 <p:sld xmlns:a="http://schemas.openxmlformats.org/drawingml/2006/main" xmlns:r="http://schemas.openxmlformats.org/officeDocument/2006/relationships" xmlns:p="http://schemas.openxmlformats.org/presentationml/2006/main">
   <p:cSld>
     <p:bg>

</xml_diff>